<commit_message>
Speaking Evals: Updated header section widths
</commit_message>
<xml_diff>
--- a/resources/assets/documents/Speaking Evaluations/SpeakingEvaluationTemplate-Full.pptx
+++ b/resources/assets/documents/Speaking Evaluations/SpeakingEvaluationTemplate-Full.pptx
@@ -4660,7 +4660,7 @@
           <p:nvPr userDrawn="1">
             <p:extLst>
               <p:ext uri="{D42A27DB-BD31-4B8C-83A1-F6EECF244321}">
-                <p14:modId xmlns:p14="http://schemas.microsoft.com/office/powerpoint/2010/main" val="3941303332"/>
+                <p14:modId xmlns:p14="http://schemas.microsoft.com/office/powerpoint/2010/main" val="3876047597"/>
               </p:ext>
             </p:extLst>
           </p:nvPr>
@@ -4690,28 +4690,28 @@
                     </a:ext>
                   </a:extLst>
                 </a:gridCol>
-                <a:gridCol w="1136616">
+                <a:gridCol w="1109225">
                   <a:extLst>
                     <a:ext uri="{9D8B030D-6E8A-4147-A177-3AD203B41FA5}">
                       <a16:colId xmlns:a16="http://schemas.microsoft.com/office/drawing/2014/main" val="20002"/>
                     </a:ext>
                   </a:extLst>
                 </a:gridCol>
-                <a:gridCol w="985067">
+                <a:gridCol w="835660">
                   <a:extLst>
                     <a:ext uri="{9D8B030D-6E8A-4147-A177-3AD203B41FA5}">
                       <a16:colId xmlns:a16="http://schemas.microsoft.com/office/drawing/2014/main" val="20003"/>
                     </a:ext>
                   </a:extLst>
                 </a:gridCol>
-                <a:gridCol w="524634">
+                <a:gridCol w="525780">
                   <a:extLst>
                     <a:ext uri="{9D8B030D-6E8A-4147-A177-3AD203B41FA5}">
                       <a16:colId xmlns:a16="http://schemas.microsoft.com/office/drawing/2014/main" val="20004"/>
                     </a:ext>
                   </a:extLst>
                 </a:gridCol>
-                <a:gridCol w="1036091">
+                <a:gridCol w="1211743">
                   <a:extLst>
                     <a:ext uri="{9D8B030D-6E8A-4147-A177-3AD203B41FA5}">
                       <a16:colId xmlns:a16="http://schemas.microsoft.com/office/drawing/2014/main" val="20005"/>
@@ -4853,6 +4853,7 @@
                     <a:p>
                       <a:pPr>
                         <a:tabLst>
+                          <a:tab pos="744538" algn="l"/>
                           <a:tab pos="1146175" algn="l"/>
                         </a:tabLst>
                       </a:pPr>
@@ -5118,6 +5119,7 @@
                     <a:p>
                       <a:pPr>
                         <a:tabLst>
+                          <a:tab pos="744538" algn="l"/>
                           <a:tab pos="1146175" algn="l"/>
                         </a:tabLst>
                       </a:pPr>

</xml_diff>

<commit_message>
Speaking Evals: Minor tweks to the standard report template
</commit_message>
<xml_diff>
--- a/resources/assets/documents/Speaking Evaluations/SpeakingEvaluationTemplate-Full.pptx
+++ b/resources/assets/documents/Speaking Evaluations/SpeakingEvaluationTemplate-Full.pptx
@@ -7683,7 +7683,7 @@
         </p:nvSpPr>
         <p:spPr>
           <a:xfrm>
-            <a:off x="5260339" y="1271016"/>
+            <a:off x="5176159" y="1271016"/>
             <a:ext cx="1259844" cy="329184"/>
           </a:xfrm>
           <a:prstGeom prst="rect">
@@ -7736,7 +7736,7 @@
         </p:nvSpPr>
         <p:spPr>
           <a:xfrm>
-            <a:off x="3861435" y="1272263"/>
+            <a:off x="3768090" y="1272263"/>
             <a:ext cx="977265" cy="292388"/>
           </a:xfrm>
           <a:prstGeom prst="rect">
@@ -7839,8 +7839,8 @@
         </p:nvSpPr>
         <p:spPr>
           <a:xfrm>
-            <a:off x="5372101" y="974554"/>
-            <a:ext cx="1036320" cy="338328"/>
+            <a:off x="5176159" y="974554"/>
+            <a:ext cx="1259844" cy="338328"/>
           </a:xfrm>
           <a:prstGeom prst="rect">
             <a:avLst/>
@@ -7869,7 +7869,7 @@
                 <a:ea typeface="A little sunshine" pitchFamily="2" charset="0"/>
                 <a:cs typeface="Segoe UI Semibold" panose="020B0702040204020203" pitchFamily="34" charset="0"/>
               </a:rPr>
-              <a:t>E6 Gaia</a:t>
+              <a:t>E4 Odysseus</a:t>
             </a:r>
             <a:endParaRPr lang="en-US" sz="2400" dirty="0">
               <a:latin typeface="Segoe UI Semibold" panose="020B0702040204020203" pitchFamily="34" charset="0"/>
@@ -7892,7 +7892,7 @@
         </p:nvSpPr>
         <p:spPr>
           <a:xfrm>
-            <a:off x="3861435" y="982307"/>
+            <a:off x="3768090" y="982307"/>
             <a:ext cx="977265" cy="292388"/>
           </a:xfrm>
           <a:prstGeom prst="rect">

</xml_diff>